<commit_message>
minor edit on the PPTX
</commit_message>
<xml_diff>
--- a/fake_news_detection_presentation.pptx
+++ b/fake_news_detection_presentation.pptx
@@ -120,6 +120,9 @@
   <p:extLst>
     <p:ext uri="{EFAFB233-063F-42B5-8137-9DF3F51BA10A}">
       <p15:sldGuideLst xmlns:p15="http://schemas.microsoft.com/office/powerpoint/2012/main"/>
+    </p:ext>
+    <p:ext uri="{2D200454-40CA-4A62-9FC3-DE9A4176ACB9}">
+      <p15:notesGuideLst xmlns:p15="http://schemas.microsoft.com/office/powerpoint/2012/main"/>
     </p:ext>
   </p:extLst>
 </p:presentation>
@@ -753,7 +756,7 @@
           <a:lstStyle/>
           <a:p>
             <a:r>
-              <a:rPr lang="en-US" dirty="0"/>
+              <a:rPr lang="en-US" sz="1200" dirty="0"/>
               <a:t>The problem. Fake news spreads roughly six times faster than real news online, and manual fact-checking simply does not scale. A single classifier model misses what humans pick up on instinctively: tone, framing, and how a piece of writing positions itself. Our approach uses four specialized CrewAI agents, each handling one part of that judgement. Claim extraction, fact-checking against external sources, bias detection, and a final judge that combines the signals. We also pulled all numerical scoring out of the LLM and into deterministic Python, which I'll come back to. For evaluation we used WELFake, 100 balanced articles from US political news between 2015 and 2017.</a:t>
             </a:r>
           </a:p>
@@ -9628,7 +9631,7 @@
           <a:prstGeom prst="rect">
             <a:avLst/>
           </a:prstGeom>
-          <a:ln w="12700">
+          <a:ln w="6350">
             <a:solidFill>
               <a:schemeClr val="tx1"/>
             </a:solidFill>

</xml_diff>

<commit_message>
Updated speaker notes and added assigned speaker per slide
</commit_message>
<xml_diff>
--- a/fake_news_detection_presentation.pptx
+++ b/fake_news_detection_presentation.pptx
@@ -488,7 +488,17 @@
           <a:p>
             <a:r>
               <a:rPr lang="en-US" dirty="0"/>
-              <a:t>Opening. Good morning. We are Luis, Asier, and Alejandro. Our project is a multi-agent fake news detection system, built on CrewAI with a local Qwen2.5:3b model and evaluated against the WELFake dataset. The headline result is 90% accuracy, but the more interesting story is what that number does and doesn't mean. I'll walk through the problem, the architecture, our results, and the engineering and methodological caveats we hit along the way.</a:t>
+              <a:t>ALE</a:t>
+            </a:r>
+            <a:br>
+              <a:rPr lang="en-US" dirty="0"/>
+            </a:br>
+            <a:br>
+              <a:rPr lang="en-US" dirty="0"/>
+            </a:br>
+            <a:r>
+              <a:rPr lang="en-US" dirty="0"/>
+              <a:t>Opening. Good morning. We are Luis, Asier, and Alejandro. Our project is a multi-agent fake news detection system, built on CrewAI with a local Qwen2.5:3b model and evaluated against the WELFake dataset. The headline result is 90% accuracy, but the more interesting story is what that number does and doesn't mean. We will walk through the problem, the architecture, our results, and the engineering and methodological caveats we hit along the way.</a:t>
             </a:r>
           </a:p>
         </p:txBody>
@@ -575,6 +585,16 @@
           <a:p>
             <a:r>
               <a:rPr lang="en-US" dirty="0"/>
+              <a:t>ASIER</a:t>
+            </a:r>
+            <a:br>
+              <a:rPr lang="en-US" dirty="0"/>
+            </a:br>
+            <a:br>
+              <a:rPr lang="en-US" dirty="0"/>
+            </a:br>
+            <a:r>
+              <a:rPr lang="en-US" dirty="0"/>
               <a:t>Four lessons that generalize beyond this project.
 ONE. Use Python for arithmetic, not LLMs. Never let an agent decide a numerical score. Extract scoring to a Python function for guaranteed reproducibility, and let the LLM only produce the human-readable explanation.
 TWO. Split search and synthesis into two tasks. output_pydantic on a search task makes agents skip tool calls entirely. Use one task to search with plain text output, then a separate task to produce structured output from those results.
@@ -666,11 +686,11 @@
           <a:p>
             <a:r>
               <a:rPr lang="en-US" dirty="0"/>
-              <a:t>To wrap up, three buckets: what worked, what didn't, and where this goes next.
-WHAT WORKED. A sequential four-agent pipeline with deterministic Python scoring via _compute_verdict. Bias detection turned out to be a reliable fallback when tool calling failed. RoBERTa contributed as a lightweight supporting signal. The system reaches 90% accuracy on WELFake using a free, local 3b model.
-WHAT DIDN'T. Local model tool calling is fragile: Qwen outputs plain text instead of structured function calls. Dataset leakage inflates the headline metric. The 3b model wins for the wrong reasons, relying on fast pattern matching over memorized data rather than genuine reasoning. Confidence is poorly calibrated: several incorrect predictions were issued at 0.93 and above, for example articles 43702 and 34392. The reported confidence reflects internal signal agreement, not a calibrated probability of correctness.
-FUTURE WORK. First, build a post-cutoff evaluation dataset for uncontaminated testing. Second, use an OpenAI backend for reliable tool use. Third, move to a parallel pipeline with agents two and three running concurrently to reduce latency. Fourth, recalibrate confidence against held-out accuracy, either via isotonic regression or coarse high, medium, and low buckets. Finally, revisit RoBERTa's five percent weight, given that it is the only component actually trained for this task.
-Happy to take questions.</a:t>
+              <a:t>ALE: To wrap up, three buckets: what worked, what didn't, and where this goes next.
+ALE: WHAT WORKED. A sequential four-agent pipeline with deterministic Python scoring via _compute_verdict. Bias detection turned out to be a reliable fallback when tool calling failed. RoBERTa contributed as a lightweight supporting signal. The system reaches 90% accuracy on WELFake using a free, local 3b model.
+LUIS: WHAT DIDN'T. Local model tool calling is fragile: Qwen outputs plain text instead of structured function calls. Dataset leakage inflates the headline metric. The 3b model wins for the wrong reasons, relying on fast pattern matching over memorized data rather than genuine reasoning. Confidence is poorly calibrated: several incorrect predictions were issued at 0.93 and above, for example articles 43702 and 34392. The reported confidence reflects internal signal agreement, not a calibrated probability of correctness.
+ASIER: FUTURE WORK. First, build a post-cutoff evaluation dataset for uncontaminated testing. Second, use an OpenAI backend for reliable tool use. Third, move to a parallel pipeline with agents two and three running concurrently to reduce latency. Fourth, recalibrate confidence against held-out accuracy, either via isotonic regression or coarse high, medium, and low buckets. Finally, revisit RoBERTa's five percent weight, given that it is the only component actually trained for this task.
+ASIER: We are happy to answer any questions.</a:t>
             </a:r>
           </a:p>
         </p:txBody>
@@ -757,7 +777,17 @@
           <a:p>
             <a:r>
               <a:rPr lang="en-US" sz="1200" dirty="0"/>
-              <a:t>The problem. Fake news spreads roughly six times faster than real news online, and manual fact-checking simply does not scale. A single classifier model misses what humans pick up on instinctively: tone, framing, and how a piece of writing positions itself. Our approach uses four specialized CrewAI agents, each handling one part of that judgement. Claim extraction, fact-checking against external sources, bias detection, and a final judge that combines the signals. We also pulled all numerical scoring out of the LLM and into deterministic Python, which I'll come back to. For evaluation we used WELFake, 100 balanced articles from US political news between 2015 and 2017.</a:t>
+              <a:t>ALE</a:t>
+            </a:r>
+            <a:br>
+              <a:rPr lang="en-US" sz="1200" dirty="0"/>
+            </a:br>
+            <a:br>
+              <a:rPr lang="en-US" sz="1200" dirty="0"/>
+            </a:br>
+            <a:r>
+              <a:rPr lang="en-US" sz="1200" dirty="0"/>
+              <a:t>The problem. Fake news spreads roughly six times faster than real news online, and manual fact-checking simply does not scale. A single classifier model misses what humans pick up on instinctively: tone, framing, and how a piece of writing positions itself. Our approach uses four specialized CrewAI agents, each handling one part of that judgement. Claim extraction, fact-checking against external sources, bias detection, and a final judge that combines the signals. We also pulled all numerical scoring out of the LLM and into deterministic Python, which we will come back to. For evaluation we used WELFake, 100 balanced articles from US political news between 2015 and 2017.</a:t>
             </a:r>
           </a:p>
         </p:txBody>
@@ -844,6 +874,16 @@
           <a:p>
             <a:r>
               <a:rPr lang="en-US" dirty="0"/>
+              <a:t>ALE</a:t>
+            </a:r>
+            <a:br>
+              <a:rPr lang="en-US" dirty="0"/>
+            </a:br>
+            <a:br>
+              <a:rPr lang="en-US" dirty="0"/>
+            </a:br>
+            <a:r>
+              <a:rPr lang="en-US" dirty="0"/>
               <a:t>Architecture walkthrough. An article enters the pipeline and the Claim Extractor produces three to five factual claims worth verifying. The Fact Checker takes each claim and searches Wikipedia and DuckDuckGo, returning supported or contradicted. The Bias Detector reads the original text and produces a bias score and tone flags, no external tools. The Judge combines those signals and emits a real or fake verdict with a confidence score. The verdict formula weights fact-checking at 60%, bias at 35%, and the RoBERTa supporting signal at 5%. Crucially, the arithmetic happens in Python, not in the LLM, which guarantees reproducibility. On sequencing: we deliberately chose sequential over parallel. The bias detector is fast because it has no tools, so running it concurrently with fact-checking saves very little wall-clock time. Concurrent logs would have made debugging the tool-use issues substantially harder, which we can talk about next.</a:t>
             </a:r>
           </a:p>
@@ -931,7 +971,17 @@
           <a:p>
             <a:r>
               <a:rPr lang="en-US" dirty="0"/>
-              <a:t>Tech stack. I'll keep this brief because the choices are mostly defensive. CrewAI handles orchestration, with sequential pipeline and built-in delegation between agents. For the LLM we used Qwen2.5:3b running locally through Ollama; the smaller model gave better results than 7b, which I'll explain when we get to caveats. Wikipedia and DuckDuckGo provide fact-checker retrieval. RoBERTa, specifically the hamzab fake news classifier on HuggingFace, gives us a small supporting signal. All scoring lives in a Python function called _compute_verdict, which guarantees reproducibility. The dataset is WELFake, 100 balanced articles for evaluation only, no fine-tuning.</a:t>
+              <a:t>LUIS</a:t>
+            </a:r>
+            <a:br>
+              <a:rPr lang="en-US" dirty="0"/>
+            </a:br>
+            <a:br>
+              <a:rPr lang="en-US" dirty="0"/>
+            </a:br>
+            <a:r>
+              <a:rPr lang="en-US" dirty="0"/>
+              <a:t>Tech stack. I'll keep this brief because the choices make sense. CrewAI handles orchestration, with sequential pipeline and built-in delegation between agents. For the LLM we used Qwen2.5:3b running locally through Ollama; the smaller model gave better results than 7b, which we will explain when we get to caveats. Wikipedia and DuckDuckGo provide fact-checker retrieval. RoBERTa, specifically the hamzab fake news classifier on HuggingFace, gives us a small supporting signal. All scoring lives in a Python function called _compute_verdict, which guarantees reproducibility. The dataset is WELFake, 100 balanced articles for evaluation only, no fine-tuning.</a:t>
             </a:r>
           </a:p>
         </p:txBody>
@@ -1016,6 +1066,16 @@
           <a:bodyPr/>
           <a:lstStyle/>
           <a:p>
+            <a:r>
+              <a:rPr lang="en-US" dirty="0"/>
+              <a:t>LUIS</a:t>
+            </a:r>
+            <a:br>
+              <a:rPr lang="en-US" dirty="0"/>
+            </a:br>
+            <a:br>
+              <a:rPr lang="en-US" dirty="0"/>
+            </a:br>
             <a:r>
               <a:rPr lang="en-US" dirty="0"/>
               <a:t>Three engineering challenges, each with a structural fix.
@@ -1126,7 +1186,17 @@
           <a:p>
             <a:r>
               <a:rPr lang="en-US" dirty="0"/>
-              <a:t>Interface</a:t>
+              <a:t>LUIS</a:t>
+            </a:r>
+            <a:br>
+              <a:rPr lang="en-US" dirty="0"/>
+            </a:br>
+            <a:br>
+              <a:rPr lang="en-US" dirty="0"/>
+            </a:br>
+            <a:r>
+              <a:rPr lang="en-US" dirty="0"/>
+              <a:t>Interface was built to handle both batch and single article analysis. We integrated backend LLM flexibility for both local and API models. A temperature level helps to give flexibility to the interpretations, and the Max claims help to set how deep you want to check the results.</a:t>
             </a:r>
           </a:p>
         </p:txBody>
@@ -1237,7 +1307,17 @@
           <a:p>
             <a:r>
               <a:rPr lang="en-US" dirty="0"/>
-              <a:t>Batch and individual processing, with outputs from the agents</a:t>
+              <a:t>LUIS</a:t>
+            </a:r>
+            <a:br>
+              <a:rPr lang="en-US" dirty="0"/>
+            </a:br>
+            <a:br>
+              <a:rPr lang="en-US" dirty="0"/>
+            </a:br>
+            <a:r>
+              <a:rPr lang="en-US" dirty="0"/>
+              <a:t>The agent outputs return each level of agent response, from the Claims Extractor Agent all the way to the judge, we can observe how the determinations are made. Fact verification, Bias, &amp; Tone are all made available. </a:t>
             </a:r>
           </a:p>
         </p:txBody>
@@ -1330,6 +1410,16 @@
           <a:p>
             <a:r>
               <a:rPr lang="en-US" dirty="0"/>
+              <a:t>ASIER</a:t>
+            </a:r>
+            <a:br>
+              <a:rPr lang="en-US" dirty="0"/>
+            </a:br>
+            <a:br>
+              <a:rPr lang="en-US" dirty="0"/>
+            </a:br>
+            <a:r>
+              <a:rPr lang="en-US" dirty="0"/>
               <a:t>Results, on the headline numbers. On 100 articles we get 90% accuracy, 0.90 F1, average confidence of 0.86, and roughly 43 seconds per article. The confusion matrix is fairly balanced. On REAL articles we got 48 right and missed 2, recall of 96%, precision 86%. On FAKE we got 42 right and missed 8, so recall is 84% and precision 96%. The asymmetry is interesting: the system is good at identifying real news and conservative when it labels something as fake. Per-class F1 is 0.91 for REAL, 0.89 for FAKE. These are strong numbers, but I want to spend the next slide explaining why they don't tell the full story.</a:t>
             </a:r>
           </a:p>
@@ -1417,7 +1507,17 @@
           <a:p>
             <a:r>
               <a:rPr lang="en-US" dirty="0"/>
-              <a:t>The 90% accuracy is misleading and I want to flag four reasons before we move on.
+              <a:t>ASIER</a:t>
+            </a:r>
+            <a:br>
+              <a:rPr lang="en-US" dirty="0"/>
+            </a:br>
+            <a:br>
+              <a:rPr lang="en-US" dirty="0"/>
+            </a:br>
+            <a:r>
+              <a:rPr lang="en-US" dirty="0"/>
+              <a:t>The 90% accuracy is misleading and we want to flag four reasons before we move on.
 ONE. Training data leakage. The model pattern-matches to articles it already knows from pretraining. High accuracy on WELFake is not real generalization, it is memorization. A truly robust evaluation requires post-cutoff data the model has never seen.
 TWO. Wikipedia search adds noise. When the model already has the answer baked in from training, retrieved search results introduce conflicting or redundant context. The model tries to reconcile its internal knowledge with the retrieved text and sometimes produces worse verdicts.
 THREE. Smaller model overthinks less. Qwen2.5:3b outperformed Qwen2.5:7b on this dataset. Not because it is smarter, but because the 3b model pattern-matches quickly to salient features. The 7b model considers counterarguments, hedges, and talks itself out of the correct answer.
@@ -1903,7 +2003,7 @@
                 <a:ea typeface="Consolas" pitchFamily="34" charset="-122"/>
                 <a:cs typeface="Consolas" pitchFamily="34" charset="-120"/>
               </a:rPr>
-              <a:t>PROJECT · FAKE NEWS DETECTION · IE MBD-PT</a:t>
+              <a:t>PROJECT · FAKE NEWS DETECTION · IE MBDS-PT</a:t>
             </a:r>
             <a:endParaRPr lang="en-US" sz="1000" dirty="0"/>
           </a:p>

</xml_diff>